<commit_message>
fix(thesis): 次要文字加深（#7F7F7F→#636363 / #6B7A8F→#566474），白底对比度 6.0:1
</commit_message>
<xml_diff>
--- a/docs/thesis/defense/答辩PPT-北航模板版.pptx
+++ b/docs/thesis/defense/答辩PPT-北航模板版.pptx
@@ -8803,7 +8803,7 @@
             <a:r>
               <a:rPr sz="1500" b="0">
                 <a:solidFill>
-                  <a:srgbClr val="7F7F7F"/>
+                  <a:srgbClr val="636363"/>
                 </a:solidFill>
                 <a:latin typeface="Arial"/>
                 <a:ea typeface="微软雅黑"/>
@@ -8883,7 +8883,7 @@
             <a:r>
               <a:rPr sz="950" b="0">
                 <a:solidFill>
-                  <a:srgbClr val="7F7F7F"/>
+                  <a:srgbClr val="636363"/>
                 </a:solidFill>
                 <a:latin typeface="Arial"/>
                 <a:ea typeface="微软雅黑"/>
@@ -9366,7 +9366,7 @@
             <a:r>
               <a:rPr sz="950" b="0">
                 <a:solidFill>
-                  <a:srgbClr val="7F7F7F"/>
+                  <a:srgbClr val="636363"/>
                 </a:solidFill>
                 <a:latin typeface="Arial"/>
                 <a:ea typeface="微软雅黑"/>
@@ -9852,7 +9852,7 @@
             <a:r>
               <a:rPr sz="1050" b="0">
                 <a:solidFill>
-                  <a:srgbClr val="7F7F7F"/>
+                  <a:srgbClr val="636363"/>
                 </a:solidFill>
                 <a:latin typeface="Arial"/>
                 <a:ea typeface="微软雅黑"/>
@@ -10050,7 +10050,7 @@
             <a:r>
               <a:rPr sz="1050" b="0">
                 <a:solidFill>
-                  <a:srgbClr val="7F7F7F"/>
+                  <a:srgbClr val="636363"/>
                 </a:solidFill>
                 <a:latin typeface="Arial"/>
                 <a:ea typeface="微软雅黑"/>
@@ -10248,7 +10248,7 @@
             <a:r>
               <a:rPr sz="1050" b="0">
                 <a:solidFill>
-                  <a:srgbClr val="7F7F7F"/>
+                  <a:srgbClr val="636363"/>
                 </a:solidFill>
                 <a:latin typeface="Arial"/>
                 <a:ea typeface="微软雅黑"/>
@@ -10446,7 +10446,7 @@
             <a:r>
               <a:rPr sz="1050" b="0">
                 <a:solidFill>
-                  <a:srgbClr val="7F7F7F"/>
+                  <a:srgbClr val="636363"/>
                 </a:solidFill>
                 <a:latin typeface="Arial"/>
                 <a:ea typeface="微软雅黑"/>
@@ -10581,7 +10581,7 @@
             <a:r>
               <a:rPr sz="950" b="0">
                 <a:solidFill>
-                  <a:srgbClr val="7F7F7F"/>
+                  <a:srgbClr val="636363"/>
                 </a:solidFill>
                 <a:latin typeface="Arial"/>
                 <a:ea typeface="微软雅黑"/>
@@ -11064,7 +11064,7 @@
             <a:r>
               <a:rPr sz="950" b="0">
                 <a:solidFill>
-                  <a:srgbClr val="7F7F7F"/>
+                  <a:srgbClr val="636363"/>
                 </a:solidFill>
                 <a:latin typeface="Arial"/>
                 <a:ea typeface="微软雅黑"/>
@@ -11849,7 +11849,7 @@
             <a:r>
               <a:rPr sz="950" b="0">
                 <a:solidFill>
-                  <a:srgbClr val="7F7F7F"/>
+                  <a:srgbClr val="636363"/>
                 </a:solidFill>
                 <a:latin typeface="Arial"/>
                 <a:ea typeface="微软雅黑"/>
@@ -12252,7 +12252,7 @@
             <a:r>
               <a:rPr sz="950" b="0">
                 <a:solidFill>
-                  <a:srgbClr val="7F7F7F"/>
+                  <a:srgbClr val="636363"/>
                 </a:solidFill>
                 <a:latin typeface="Arial"/>
                 <a:ea typeface="微软雅黑"/>
@@ -12434,7 +12434,7 @@
             <a:r>
               <a:rPr sz="800" b="0">
                 <a:solidFill>
-                  <a:srgbClr val="7F7F7F"/>
+                  <a:srgbClr val="636363"/>
                 </a:solidFill>
                 <a:latin typeface="Arial"/>
                 <a:ea typeface="微软雅黑"/>
@@ -12536,7 +12536,7 @@
             <a:r>
               <a:rPr sz="800" b="0">
                 <a:solidFill>
-                  <a:srgbClr val="7F7F7F"/>
+                  <a:srgbClr val="636363"/>
                 </a:solidFill>
                 <a:latin typeface="Arial"/>
                 <a:ea typeface="微软雅黑"/>
@@ -12638,7 +12638,7 @@
             <a:r>
               <a:rPr sz="800" b="0">
                 <a:solidFill>
-                  <a:srgbClr val="7F7F7F"/>
+                  <a:srgbClr val="636363"/>
                 </a:solidFill>
                 <a:latin typeface="Arial"/>
                 <a:ea typeface="微软雅黑"/>
@@ -12740,7 +12740,7 @@
             <a:r>
               <a:rPr sz="800" b="0">
                 <a:solidFill>
-                  <a:srgbClr val="7F7F7F"/>
+                  <a:srgbClr val="636363"/>
                 </a:solidFill>
                 <a:latin typeface="Arial"/>
                 <a:ea typeface="微软雅黑"/>
@@ -12842,7 +12842,7 @@
             <a:r>
               <a:rPr sz="800" b="0">
                 <a:solidFill>
-                  <a:srgbClr val="7F7F7F"/>
+                  <a:srgbClr val="636363"/>
                 </a:solidFill>
                 <a:latin typeface="Arial"/>
                 <a:ea typeface="微软雅黑"/>
@@ -12944,7 +12944,7 @@
             <a:r>
               <a:rPr sz="800" b="0">
                 <a:solidFill>
-                  <a:srgbClr val="7F7F7F"/>
+                  <a:srgbClr val="636363"/>
                 </a:solidFill>
                 <a:latin typeface="Arial"/>
                 <a:ea typeface="微软雅黑"/>
@@ -12980,7 +12980,7 @@
             <a:r>
               <a:rPr sz="850" b="0">
                 <a:solidFill>
-                  <a:srgbClr val="7F7F7F"/>
+                  <a:srgbClr val="636363"/>
                 </a:solidFill>
                 <a:latin typeface="Arial"/>
                 <a:ea typeface="微软雅黑"/>
@@ -13016,7 +13016,7 @@
             <a:r>
               <a:rPr sz="950" b="0">
                 <a:solidFill>
-                  <a:srgbClr val="7F7F7F"/>
+                  <a:srgbClr val="636363"/>
                 </a:solidFill>
                 <a:latin typeface="Arial"/>
                 <a:ea typeface="微软雅黑"/>
@@ -13521,7 +13521,7 @@
             <a:r>
               <a:rPr sz="1200" b="0">
                 <a:solidFill>
-                  <a:srgbClr val="7F7F7F"/>
+                  <a:srgbClr val="636363"/>
                 </a:solidFill>
                 <a:latin typeface="Arial"/>
                 <a:ea typeface="微软雅黑"/>
@@ -13683,7 +13683,7 @@
             <a:r>
               <a:rPr sz="1200" b="0">
                 <a:solidFill>
-                  <a:srgbClr val="7F7F7F"/>
+                  <a:srgbClr val="636363"/>
                 </a:solidFill>
                 <a:latin typeface="Arial"/>
                 <a:ea typeface="微软雅黑"/>
@@ -13845,7 +13845,7 @@
             <a:r>
               <a:rPr sz="1200" b="0">
                 <a:solidFill>
-                  <a:srgbClr val="7F7F7F"/>
+                  <a:srgbClr val="636363"/>
                 </a:solidFill>
                 <a:latin typeface="Arial"/>
                 <a:ea typeface="微软雅黑"/>
@@ -13961,7 +13961,7 @@
             <a:r>
               <a:rPr sz="950" b="0">
                 <a:solidFill>
-                  <a:srgbClr val="7F7F7F"/>
+                  <a:srgbClr val="636363"/>
                 </a:solidFill>
                 <a:latin typeface="Arial"/>
                 <a:ea typeface="微软雅黑"/>
@@ -14444,7 +14444,7 @@
             <a:r>
               <a:rPr sz="850" b="0">
                 <a:solidFill>
-                  <a:srgbClr val="7F7F7F"/>
+                  <a:srgbClr val="636363"/>
                 </a:solidFill>
                 <a:latin typeface="Arial"/>
                 <a:ea typeface="微软雅黑"/>
@@ -14480,7 +14480,7 @@
             <a:r>
               <a:rPr sz="950" b="0">
                 <a:solidFill>
-                  <a:srgbClr val="7F7F7F"/>
+                  <a:srgbClr val="636363"/>
                 </a:solidFill>
                 <a:latin typeface="Arial"/>
                 <a:ea typeface="微软雅黑"/>
@@ -14963,7 +14963,7 @@
             <a:r>
               <a:rPr sz="850" b="0">
                 <a:solidFill>
-                  <a:srgbClr val="7F7F7F"/>
+                  <a:srgbClr val="636363"/>
                 </a:solidFill>
                 <a:latin typeface="Arial"/>
                 <a:ea typeface="微软雅黑"/>
@@ -14999,7 +14999,7 @@
             <a:r>
               <a:rPr sz="950" b="0">
                 <a:solidFill>
-                  <a:srgbClr val="7F7F7F"/>
+                  <a:srgbClr val="636363"/>
                 </a:solidFill>
                 <a:latin typeface="Arial"/>
                 <a:ea typeface="微软雅黑"/>
@@ -15950,7 +15950,7 @@
             <a:r>
               <a:rPr sz="850" b="0">
                 <a:solidFill>
-                  <a:srgbClr val="7F7F7F"/>
+                  <a:srgbClr val="636363"/>
                 </a:solidFill>
                 <a:latin typeface="Arial"/>
                 <a:ea typeface="微软雅黑"/>
@@ -15986,7 +15986,7 @@
             <a:r>
               <a:rPr sz="950" b="0">
                 <a:solidFill>
-                  <a:srgbClr val="7F7F7F"/>
+                  <a:srgbClr val="636363"/>
                 </a:solidFill>
                 <a:latin typeface="Arial"/>
                 <a:ea typeface="微软雅黑"/>
@@ -16469,7 +16469,7 @@
             <a:r>
               <a:rPr sz="850" b="0">
                 <a:solidFill>
-                  <a:srgbClr val="7F7F7F"/>
+                  <a:srgbClr val="636363"/>
                 </a:solidFill>
                 <a:latin typeface="Arial"/>
                 <a:ea typeface="微软雅黑"/>
@@ -16505,7 +16505,7 @@
             <a:r>
               <a:rPr sz="950" b="0">
                 <a:solidFill>
-                  <a:srgbClr val="7F7F7F"/>
+                  <a:srgbClr val="636363"/>
                 </a:solidFill>
                 <a:latin typeface="Arial"/>
                 <a:ea typeface="微软雅黑"/>
@@ -17482,7 +17482,7 @@
             <a:r>
               <a:rPr sz="950" b="0">
                 <a:solidFill>
-                  <a:srgbClr val="7F7F7F"/>
+                  <a:srgbClr val="636363"/>
                 </a:solidFill>
                 <a:latin typeface="Arial"/>
                 <a:ea typeface="微软雅黑"/>
@@ -17965,7 +17965,7 @@
             <a:r>
               <a:rPr sz="850" b="0">
                 <a:solidFill>
-                  <a:srgbClr val="7F7F7F"/>
+                  <a:srgbClr val="636363"/>
                 </a:solidFill>
                 <a:latin typeface="Arial"/>
                 <a:ea typeface="微软雅黑"/>
@@ -18001,7 +18001,7 @@
             <a:r>
               <a:rPr sz="950" b="0">
                 <a:solidFill>
-                  <a:srgbClr val="7F7F7F"/>
+                  <a:srgbClr val="636363"/>
                 </a:solidFill>
                 <a:latin typeface="Arial"/>
                 <a:ea typeface="微软雅黑"/>
@@ -18727,7 +18727,7 @@
             <a:r>
               <a:rPr sz="950" b="0">
                 <a:solidFill>
-                  <a:srgbClr val="7F7F7F"/>
+                  <a:srgbClr val="636363"/>
                 </a:solidFill>
                 <a:latin typeface="Arial"/>
                 <a:ea typeface="微软雅黑"/>
@@ -18843,7 +18843,7 @@
             <a:r>
               <a:rPr sz="850" b="0">
                 <a:solidFill>
-                  <a:srgbClr val="7F7F7F"/>
+                  <a:srgbClr val="636363"/>
                 </a:solidFill>
                 <a:latin typeface="Arial"/>
                 <a:ea typeface="微软雅黑"/>
@@ -18879,7 +18879,7 @@
             <a:r>
               <a:rPr sz="950" b="0">
                 <a:solidFill>
-                  <a:srgbClr val="7F7F7F"/>
+                  <a:srgbClr val="636363"/>
                 </a:solidFill>
                 <a:latin typeface="Arial"/>
                 <a:ea typeface="微软雅黑"/>
@@ -19735,7 +19735,7 @@
             <a:r>
               <a:rPr sz="850" b="0">
                 <a:solidFill>
-                  <a:srgbClr val="7F7F7F"/>
+                  <a:srgbClr val="636363"/>
                 </a:solidFill>
                 <a:latin typeface="Arial"/>
                 <a:ea typeface="微软雅黑"/>
@@ -19771,7 +19771,7 @@
             <a:r>
               <a:rPr sz="950" b="0">
                 <a:solidFill>
-                  <a:srgbClr val="7F7F7F"/>
+                  <a:srgbClr val="636363"/>
                 </a:solidFill>
                 <a:latin typeface="Arial"/>
                 <a:ea typeface="微软雅黑"/>
@@ -20627,7 +20627,7 @@
             <a:r>
               <a:rPr sz="850" b="0">
                 <a:solidFill>
-                  <a:srgbClr val="7F7F7F"/>
+                  <a:srgbClr val="636363"/>
                 </a:solidFill>
                 <a:latin typeface="Arial"/>
                 <a:ea typeface="微软雅黑"/>
@@ -20663,7 +20663,7 @@
             <a:r>
               <a:rPr sz="950" b="0">
                 <a:solidFill>
-                  <a:srgbClr val="7F7F7F"/>
+                  <a:srgbClr val="636363"/>
                 </a:solidFill>
                 <a:latin typeface="Arial"/>
                 <a:ea typeface="微软雅黑"/>
@@ -21978,7 +21978,7 @@
             <a:r>
               <a:rPr sz="950" b="0">
                 <a:solidFill>
-                  <a:srgbClr val="7F7F7F"/>
+                  <a:srgbClr val="636363"/>
                 </a:solidFill>
                 <a:latin typeface="Arial"/>
                 <a:ea typeface="微软雅黑"/>
@@ -23293,7 +23293,7 @@
             <a:r>
               <a:rPr sz="950" b="0">
                 <a:solidFill>
-                  <a:srgbClr val="7F7F7F"/>
+                  <a:srgbClr val="636363"/>
                 </a:solidFill>
                 <a:latin typeface="Arial"/>
                 <a:ea typeface="微软雅黑"/>
@@ -23435,7 +23435,7 @@
             <a:r>
               <a:rPr sz="1600" b="0">
                 <a:solidFill>
-                  <a:srgbClr val="7F7F7F"/>
+                  <a:srgbClr val="636363"/>
                 </a:solidFill>
                 <a:latin typeface="Arial"/>
                 <a:ea typeface="微软雅黑"/>
@@ -23471,7 +23471,7 @@
             <a:r>
               <a:rPr sz="1300" b="0">
                 <a:solidFill>
-                  <a:srgbClr val="7F7F7F"/>
+                  <a:srgbClr val="636363"/>
                 </a:solidFill>
                 <a:latin typeface="Arial"/>
                 <a:ea typeface="微软雅黑"/>
@@ -23488,7 +23488,7 @@
             <a:r>
               <a:rPr sz="1300" b="0">
                 <a:solidFill>
-                  <a:srgbClr val="7F7F7F"/>
+                  <a:srgbClr val="636363"/>
                 </a:solidFill>
                 <a:latin typeface="Arial"/>
                 <a:ea typeface="微软雅黑"/>
@@ -23612,7 +23612,7 @@
             <a:r>
               <a:rPr sz="950" b="0">
                 <a:solidFill>
-                  <a:srgbClr val="7F7F7F"/>
+                  <a:srgbClr val="636363"/>
                 </a:solidFill>
                 <a:latin typeface="Arial"/>
                 <a:ea typeface="微软雅黑"/>
@@ -24954,7 +24954,7 @@
             <a:r>
               <a:rPr sz="950" b="0">
                 <a:solidFill>
-                  <a:srgbClr val="7F7F7F"/>
+                  <a:srgbClr val="636363"/>
                 </a:solidFill>
                 <a:latin typeface="Arial"/>
                 <a:ea typeface="微软雅黑"/>
@@ -25958,7 +25958,7 @@
             <a:r>
               <a:rPr sz="950" b="0">
                 <a:solidFill>
-                  <a:srgbClr val="7F7F7F"/>
+                  <a:srgbClr val="636363"/>
                 </a:solidFill>
                 <a:latin typeface="Arial"/>
                 <a:ea typeface="微软雅黑"/>
@@ -26417,7 +26417,7 @@
             <a:r>
               <a:rPr sz="950" b="0">
                 <a:solidFill>
-                  <a:srgbClr val="7F7F7F"/>
+                  <a:srgbClr val="636363"/>
                 </a:solidFill>
                 <a:latin typeface="Arial"/>
                 <a:ea typeface="微软雅黑"/>
@@ -27688,7 +27688,7 @@
             <a:r>
               <a:rPr sz="950" b="0">
                 <a:solidFill>
-                  <a:srgbClr val="7F7F7F"/>
+                  <a:srgbClr val="636363"/>
                 </a:solidFill>
                 <a:latin typeface="Arial"/>
                 <a:ea typeface="微软雅黑"/>
@@ -28664,7 +28664,7 @@
             <a:r>
               <a:rPr sz="950" b="0">
                 <a:solidFill>
-                  <a:srgbClr val="7F7F7F"/>
+                  <a:srgbClr val="636363"/>
                 </a:solidFill>
                 <a:latin typeface="Arial"/>
                 <a:ea typeface="微软雅黑"/>
@@ -29123,7 +29123,7 @@
             <a:r>
               <a:rPr sz="950" b="0">
                 <a:solidFill>
-                  <a:srgbClr val="7F7F7F"/>
+                  <a:srgbClr val="636363"/>
                 </a:solidFill>
                 <a:latin typeface="Arial"/>
                 <a:ea typeface="微软雅黑"/>
@@ -29582,7 +29582,7 @@
             <a:r>
               <a:rPr sz="950" b="0">
                 <a:solidFill>
-                  <a:srgbClr val="7F7F7F"/>
+                  <a:srgbClr val="636363"/>
                 </a:solidFill>
                 <a:latin typeface="Arial"/>
                 <a:ea typeface="微软雅黑"/>
@@ -30079,7 +30079,7 @@
             <a:r>
               <a:rPr sz="950" b="0">
                 <a:solidFill>
-                  <a:srgbClr val="7F7F7F"/>
+                  <a:srgbClr val="636363"/>
                 </a:solidFill>
                 <a:latin typeface="Arial"/>
                 <a:ea typeface="微软雅黑"/>
@@ -30900,7 +30900,7 @@
             <a:r>
               <a:rPr sz="950" b="0">
                 <a:solidFill>
-                  <a:srgbClr val="7F7F7F"/>
+                  <a:srgbClr val="636363"/>
                 </a:solidFill>
                 <a:latin typeface="Arial"/>
                 <a:ea typeface="微软雅黑"/>
@@ -31383,7 +31383,7 @@
             <a:r>
               <a:rPr sz="950" b="0">
                 <a:solidFill>
-                  <a:srgbClr val="7F7F7F"/>
+                  <a:srgbClr val="636363"/>
                 </a:solidFill>
                 <a:latin typeface="Arial"/>
                 <a:ea typeface="微软雅黑"/>
@@ -31866,7 +31866,7 @@
             <a:r>
               <a:rPr sz="950" b="0">
                 <a:solidFill>
-                  <a:srgbClr val="7F7F7F"/>
+                  <a:srgbClr val="636363"/>
                 </a:solidFill>
                 <a:latin typeface="Arial"/>
                 <a:ea typeface="微软雅黑"/>
@@ -32349,7 +32349,7 @@
             <a:r>
               <a:rPr sz="950" b="0">
                 <a:solidFill>
-                  <a:srgbClr val="7F7F7F"/>
+                  <a:srgbClr val="636363"/>
                 </a:solidFill>
                 <a:latin typeface="Arial"/>
                 <a:ea typeface="微软雅黑"/>
@@ -32832,7 +32832,7 @@
             <a:r>
               <a:rPr sz="950" b="0">
                 <a:solidFill>
-                  <a:srgbClr val="7F7F7F"/>
+                  <a:srgbClr val="636363"/>
                 </a:solidFill>
                 <a:latin typeface="Arial"/>
                 <a:ea typeface="微软雅黑"/>
@@ -33329,7 +33329,7 @@
             <a:r>
               <a:rPr sz="950" b="0">
                 <a:solidFill>
-                  <a:srgbClr val="7F7F7F"/>
+                  <a:srgbClr val="636363"/>
                 </a:solidFill>
                 <a:latin typeface="Arial"/>
                 <a:ea typeface="微软雅黑"/>

</xml_diff>

<commit_message>
feat(thesis): Dispatcher / Scheduler 流程页改为与架构图一致的版式
按作者要求，第 6、7 页沿用第 5 页的处理方式：

- 去掉核心句与左侧要点栏，流程图居中放大（6.41×4.05、6.20×4.05 in）
- 图下方三列说明卡（白底 + 左侧深蓝条，标题 15pt、正文 12.5pt）：
  · Dispatcher：① 归属校验 ② 分区选择 ③ 入队
  · Scheduler：① Filter ② Score ③ Reserve / Permit
- 三页（P5/P6/P7）现在视觉结构完全一致：居中大图 + 图下三块说明

校验：32 页、无越界、三块说明估算高度均未超出卡片；讲稿不变（18.8 分钟）。
</commit_message>
<xml_diff>
--- a/docs/thesis/defense/答辩PPT-北航模板版.pptx
+++ b/docs/thesis/defense/答辩PPT-北航模板版.pptx
@@ -29869,49 +29869,9 @@
           </a:p>
         </p:txBody>
       </p:sp>
-      <p:sp>
-        <p:nvSpPr>
-          <p:cNvPr id="9003" name="TextBox 9002"/>
-          <p:cNvSpPr txBox="1"/>
-          <p:nvPr/>
-        </p:nvSpPr>
-        <p:spPr>
-          <a:xfrm>
-            <a:off x="566928" y="1261872"/>
-            <a:ext cx="10881360" cy="438912"/>
-          </a:xfrm>
-          <a:prstGeom prst="rect">
-            <a:avLst/>
-          </a:prstGeom>
-          <a:noFill/>
-        </p:spPr>
-        <p:txBody>
-          <a:bodyPr wrap="square" anchor="ctr" lIns="0" rIns="0" tIns="0" bIns="0">
-            <a:spAutoFit/>
-          </a:bodyPr>
-          <a:lstStyle/>
-          <a:p>
-            <a:pPr algn="l">
-              <a:lnSpc>
-                <a:spcPct val="110000"/>
-              </a:lnSpc>
-            </a:pPr>
-            <a:r>
-              <a:rPr sz="1800" b="1">
-                <a:solidFill>
-                  <a:srgbClr val="0070C0"/>
-                </a:solidFill>
-                <a:latin typeface="Arial"/>
-                <a:ea typeface="微软雅黑"/>
-              </a:rPr>
-              <a:t>先校验归属、再选分区、然后入队——它不选节点，只决定 Pod 去哪</a:t>
-            </a:r>
-          </a:p>
-        </p:txBody>
-      </p:sp>
       <p:pic>
         <p:nvPicPr>
-          <p:cNvPr id="9004" name="Picture 9003" descr="fig3-3-dispatcher-flow.png"/>
+          <p:cNvPr id="9003" name="Picture 9002" descr="fig3-3-dispatcher-flow.png"/>
           <p:cNvPicPr>
             <a:picLocks noChangeAspect="1"/>
           </p:cNvPicPr>
@@ -29925,8 +29885,8 @@
         </p:blipFill>
         <p:spPr>
           <a:xfrm>
-            <a:off x="4892040" y="1666984"/>
-            <a:ext cx="6720840" cy="4246406"/>
+            <a:off x="3150114" y="868680"/>
+            <a:ext cx="5861290" cy="3703320"/>
           </a:xfrm>
           <a:prstGeom prst="rect">
             <a:avLst/>
@@ -29935,14 +29895,104 @@
       </p:pic>
       <p:sp>
         <p:nvSpPr>
-          <p:cNvPr id="9005" name="TextBox 9004"/>
+          <p:cNvPr id="9004" name="Rounded Rectangle 9003"/>
+          <p:cNvSpPr/>
+          <p:nvPr/>
+        </p:nvSpPr>
+        <p:spPr>
+          <a:xfrm>
+            <a:off x="566928" y="4754880"/>
+            <a:ext cx="3535680" cy="1417320"/>
+          </a:xfrm>
+          <a:prstGeom prst="roundRect">
+            <a:avLst/>
+          </a:prstGeom>
+          <a:solidFill>
+            <a:srgbClr val="FFFFFF"/>
+          </a:solidFill>
+          <a:ln w="9525">
+            <a:solidFill>
+              <a:srgbClr val="D6E3F0"/>
+            </a:solidFill>
+          </a:ln>
+          <a:effectLst/>
+        </p:spPr>
+        <p:style>
+          <a:lnRef idx="1">
+            <a:schemeClr val="accent1"/>
+          </a:lnRef>
+          <a:fillRef idx="3">
+            <a:schemeClr val="accent1"/>
+          </a:fillRef>
+          <a:effectRef idx="2">
+            <a:schemeClr val="accent1"/>
+          </a:effectRef>
+          <a:fontRef idx="minor">
+            <a:schemeClr val="lt1"/>
+          </a:fontRef>
+        </p:style>
+        <p:txBody>
+          <a:bodyPr rtlCol="0" anchor="ctr"/>
+          <a:lstStyle/>
+          <a:p>
+            <a:pPr algn="ctr"/>
+          </a:p>
+        </p:txBody>
+      </p:sp>
+      <p:sp>
+        <p:nvSpPr>
+          <p:cNvPr id="9005" name="Rectangle 9004"/>
+          <p:cNvSpPr/>
+          <p:nvPr/>
+        </p:nvSpPr>
+        <p:spPr>
+          <a:xfrm>
+            <a:off x="566928" y="4754880"/>
+            <a:ext cx="50292" cy="1417320"/>
+          </a:xfrm>
+          <a:prstGeom prst="rect">
+            <a:avLst/>
+          </a:prstGeom>
+          <a:solidFill>
+            <a:srgbClr val="113E6A"/>
+          </a:solidFill>
+          <a:ln>
+            <a:noFill/>
+          </a:ln>
+          <a:effectLst/>
+        </p:spPr>
+        <p:style>
+          <a:lnRef idx="1">
+            <a:schemeClr val="accent1"/>
+          </a:lnRef>
+          <a:fillRef idx="3">
+            <a:schemeClr val="accent1"/>
+          </a:fillRef>
+          <a:effectRef idx="2">
+            <a:schemeClr val="accent1"/>
+          </a:effectRef>
+          <a:fontRef idx="minor">
+            <a:schemeClr val="lt1"/>
+          </a:fontRef>
+        </p:style>
+        <p:txBody>
+          <a:bodyPr rtlCol="0" anchor="ctr"/>
+          <a:lstStyle/>
+          <a:p>
+            <a:pPr algn="ctr"/>
+          </a:p>
+        </p:txBody>
+      </p:sp>
+      <p:sp>
+        <p:nvSpPr>
+          <p:cNvPr id="9006" name="TextBox 9005"/>
           <p:cNvSpPr txBox="1"/>
           <p:nvPr/>
         </p:nvSpPr>
         <p:spPr>
           <a:xfrm>
-            <a:off x="566928" y="2011680"/>
-            <a:ext cx="4160520" cy="1417320"/>
+            <a:off x="749808" y="4864608"/>
+            <a:ext cx="3224784" cy="1234440"/>
           </a:xfrm>
           <a:prstGeom prst="rect">
             <a:avLst/>
@@ -29955,67 +30005,335 @@
           </a:bodyPr>
           <a:lstStyle/>
           <a:p>
+            <a:pPr algn="l"/>
+            <a:r>
+              <a:rPr sz="1500" b="1">
+                <a:solidFill>
+                  <a:srgbClr val="113E6A"/>
+                </a:solidFill>
+                <a:latin typeface="Arial"/>
+                <a:ea typeface="微软雅黑"/>
+              </a:rPr>
+              <a:t>① 归属校验</a:t>
+            </a:r>
+          </a:p>
+          <a:p>
             <a:pPr algn="l">
               <a:lnSpc>
-                <a:spcPct val="115000"/>
+                <a:spcPct val="118000"/>
               </a:lnSpc>
+              <a:spcBef>
+                <a:spcPts val="400"/>
+              </a:spcBef>
             </a:pPr>
             <a:r>
-              <a:rPr sz="1550" b="0">
+              <a:rPr sz="1250" b="0">
                 <a:solidFill>
                   <a:srgbClr val="2E2C2C"/>
                 </a:solidFill>
                 <a:latin typeface="Arial"/>
                 <a:ea typeface="微软雅黑"/>
               </a:rPr>
-              <a:t>▪  归属校验：把漂移的 Pod 拦住</a:t>
+              <a:t>Bind 前校验目标节点的 eno.io/scheduler-name 注解，把分区归属漂移的 Pod 拦在门外</a:t>
+            </a:r>
+          </a:p>
+        </p:txBody>
+      </p:sp>
+      <p:sp>
+        <p:nvSpPr>
+          <p:cNvPr id="9007" name="Rounded Rectangle 9006"/>
+          <p:cNvSpPr/>
+          <p:nvPr/>
+        </p:nvSpPr>
+        <p:spPr>
+          <a:xfrm>
+            <a:off x="4331208" y="4754880"/>
+            <a:ext cx="3535680" cy="1417320"/>
+          </a:xfrm>
+          <a:prstGeom prst="roundRect">
+            <a:avLst/>
+          </a:prstGeom>
+          <a:solidFill>
+            <a:srgbClr val="FFFFFF"/>
+          </a:solidFill>
+          <a:ln w="9525">
+            <a:solidFill>
+              <a:srgbClr val="D6E3F0"/>
+            </a:solidFill>
+          </a:ln>
+          <a:effectLst/>
+        </p:spPr>
+        <p:style>
+          <a:lnRef idx="1">
+            <a:schemeClr val="accent1"/>
+          </a:lnRef>
+          <a:fillRef idx="3">
+            <a:schemeClr val="accent1"/>
+          </a:fillRef>
+          <a:effectRef idx="2">
+            <a:schemeClr val="accent1"/>
+          </a:effectRef>
+          <a:fontRef idx="minor">
+            <a:schemeClr val="lt1"/>
+          </a:fontRef>
+        </p:style>
+        <p:txBody>
+          <a:bodyPr rtlCol="0" anchor="ctr"/>
+          <a:lstStyle/>
+          <a:p>
+            <a:pPr algn="ctr"/>
+          </a:p>
+        </p:txBody>
+      </p:sp>
+      <p:sp>
+        <p:nvSpPr>
+          <p:cNvPr id="9008" name="Rectangle 9007"/>
+          <p:cNvSpPr/>
+          <p:nvPr/>
+        </p:nvSpPr>
+        <p:spPr>
+          <a:xfrm>
+            <a:off x="4331208" y="4754880"/>
+            <a:ext cx="50292" cy="1417320"/>
+          </a:xfrm>
+          <a:prstGeom prst="rect">
+            <a:avLst/>
+          </a:prstGeom>
+          <a:solidFill>
+            <a:srgbClr val="113E6A"/>
+          </a:solidFill>
+          <a:ln>
+            <a:noFill/>
+          </a:ln>
+          <a:effectLst/>
+        </p:spPr>
+        <p:style>
+          <a:lnRef idx="1">
+            <a:schemeClr val="accent1"/>
+          </a:lnRef>
+          <a:fillRef idx="3">
+            <a:schemeClr val="accent1"/>
+          </a:fillRef>
+          <a:effectRef idx="2">
+            <a:schemeClr val="accent1"/>
+          </a:effectRef>
+          <a:fontRef idx="minor">
+            <a:schemeClr val="lt1"/>
+          </a:fontRef>
+        </p:style>
+        <p:txBody>
+          <a:bodyPr rtlCol="0" anchor="ctr"/>
+          <a:lstStyle/>
+          <a:p>
+            <a:pPr algn="ctr"/>
+          </a:p>
+        </p:txBody>
+      </p:sp>
+      <p:sp>
+        <p:nvSpPr>
+          <p:cNvPr id="9009" name="TextBox 9008"/>
+          <p:cNvSpPr txBox="1"/>
+          <p:nvPr/>
+        </p:nvSpPr>
+        <p:spPr>
+          <a:xfrm>
+            <a:off x="4514088" y="4864608"/>
+            <a:ext cx="3224784" cy="1234440"/>
+          </a:xfrm>
+          <a:prstGeom prst="rect">
+            <a:avLst/>
+          </a:prstGeom>
+          <a:noFill/>
+        </p:spPr>
+        <p:txBody>
+          <a:bodyPr wrap="square" anchor="t" lIns="0" rIns="0" tIns="0" bIns="0">
+            <a:spAutoFit/>
+          </a:bodyPr>
+          <a:lstStyle/>
+          <a:p>
+            <a:pPr algn="l"/>
+            <a:r>
+              <a:rPr sz="1500" b="1">
+                <a:solidFill>
+                  <a:srgbClr val="113E6A"/>
+                </a:solidFill>
+                <a:latin typeface="Arial"/>
+                <a:ea typeface="微软雅黑"/>
+              </a:rPr>
+              <a:t>② 分区选择</a:t>
             </a:r>
           </a:p>
           <a:p>
             <a:pPr algn="l">
               <a:lnSpc>
-                <a:spcPct val="115000"/>
+                <a:spcPct val="118000"/>
               </a:lnSpc>
               <a:spcBef>
-                <a:spcPts val="1400"/>
+                <a:spcPts val="400"/>
               </a:spcBef>
             </a:pPr>
             <a:r>
-              <a:rPr sz="1550" b="0">
+              <a:rPr sz="1250" b="0">
                 <a:solidFill>
                   <a:srgbClr val="2E2C2C"/>
                 </a:solidFill>
                 <a:latin typeface="Arial"/>
                 <a:ea typeface="微软雅黑"/>
               </a:rPr>
-              <a:t>▪  分区选择：按实例负载均衡</a:t>
+              <a:t>依据节点分区表与实例负载，决定这个 Pod 交给哪个 Scheduler 实例处理</a:t>
+            </a:r>
+          </a:p>
+        </p:txBody>
+      </p:sp>
+      <p:sp>
+        <p:nvSpPr>
+          <p:cNvPr id="9010" name="Rounded Rectangle 9009"/>
+          <p:cNvSpPr/>
+          <p:nvPr/>
+        </p:nvSpPr>
+        <p:spPr>
+          <a:xfrm>
+            <a:off x="8095488" y="4754880"/>
+            <a:ext cx="3535680" cy="1417320"/>
+          </a:xfrm>
+          <a:prstGeom prst="roundRect">
+            <a:avLst/>
+          </a:prstGeom>
+          <a:solidFill>
+            <a:srgbClr val="FFFFFF"/>
+          </a:solidFill>
+          <a:ln w="9525">
+            <a:solidFill>
+              <a:srgbClr val="D6E3F0"/>
+            </a:solidFill>
+          </a:ln>
+          <a:effectLst/>
+        </p:spPr>
+        <p:style>
+          <a:lnRef idx="1">
+            <a:schemeClr val="accent1"/>
+          </a:lnRef>
+          <a:fillRef idx="3">
+            <a:schemeClr val="accent1"/>
+          </a:fillRef>
+          <a:effectRef idx="2">
+            <a:schemeClr val="accent1"/>
+          </a:effectRef>
+          <a:fontRef idx="minor">
+            <a:schemeClr val="lt1"/>
+          </a:fontRef>
+        </p:style>
+        <p:txBody>
+          <a:bodyPr rtlCol="0" anchor="ctr"/>
+          <a:lstStyle/>
+          <a:p>
+            <a:pPr algn="ctr"/>
+          </a:p>
+        </p:txBody>
+      </p:sp>
+      <p:sp>
+        <p:nvSpPr>
+          <p:cNvPr id="9011" name="Rectangle 9010"/>
+          <p:cNvSpPr/>
+          <p:nvPr/>
+        </p:nvSpPr>
+        <p:spPr>
+          <a:xfrm>
+            <a:off x="8095488" y="4754880"/>
+            <a:ext cx="50292" cy="1417320"/>
+          </a:xfrm>
+          <a:prstGeom prst="rect">
+            <a:avLst/>
+          </a:prstGeom>
+          <a:solidFill>
+            <a:srgbClr val="113E6A"/>
+          </a:solidFill>
+          <a:ln>
+            <a:noFill/>
+          </a:ln>
+          <a:effectLst/>
+        </p:spPr>
+        <p:style>
+          <a:lnRef idx="1">
+            <a:schemeClr val="accent1"/>
+          </a:lnRef>
+          <a:fillRef idx="3">
+            <a:schemeClr val="accent1"/>
+          </a:fillRef>
+          <a:effectRef idx="2">
+            <a:schemeClr val="accent1"/>
+          </a:effectRef>
+          <a:fontRef idx="minor">
+            <a:schemeClr val="lt1"/>
+          </a:fontRef>
+        </p:style>
+        <p:txBody>
+          <a:bodyPr rtlCol="0" anchor="ctr"/>
+          <a:lstStyle/>
+          <a:p>
+            <a:pPr algn="ctr"/>
+          </a:p>
+        </p:txBody>
+      </p:sp>
+      <p:sp>
+        <p:nvSpPr>
+          <p:cNvPr id="9012" name="TextBox 9011"/>
+          <p:cNvSpPr txBox="1"/>
+          <p:nvPr/>
+        </p:nvSpPr>
+        <p:spPr>
+          <a:xfrm>
+            <a:off x="8278367" y="4864608"/>
+            <a:ext cx="3224784" cy="1234440"/>
+          </a:xfrm>
+          <a:prstGeom prst="rect">
+            <a:avLst/>
+          </a:prstGeom>
+          <a:noFill/>
+        </p:spPr>
+        <p:txBody>
+          <a:bodyPr wrap="square" anchor="t" lIns="0" rIns="0" tIns="0" bIns="0">
+            <a:spAutoFit/>
+          </a:bodyPr>
+          <a:lstStyle/>
+          <a:p>
+            <a:pPr algn="l"/>
+            <a:r>
+              <a:rPr sz="1500" b="1">
+                <a:solidFill>
+                  <a:srgbClr val="113E6A"/>
+                </a:solidFill>
+                <a:latin typeface="Arial"/>
+                <a:ea typeface="微软雅黑"/>
+              </a:rPr>
+              <a:t>③ 入队</a:t>
             </a:r>
           </a:p>
           <a:p>
             <a:pPr algn="l">
               <a:lnSpc>
-                <a:spcPct val="115000"/>
+                <a:spcPct val="118000"/>
               </a:lnSpc>
               <a:spcBef>
-                <a:spcPts val="1400"/>
+                <a:spcPts val="400"/>
               </a:spcBef>
             </a:pPr>
             <a:r>
-              <a:rPr sz="1550" b="0">
+              <a:rPr sz="1250" b="0">
                 <a:solidFill>
                   <a:srgbClr val="2E2C2C"/>
                 </a:solidFill>
                 <a:latin typeface="Arial"/>
                 <a:ea typeface="微软雅黑"/>
               </a:rPr>
-              <a:t>▪  入队：交给对应 Scheduler 实例</a:t>
-            </a:r>
-          </a:p>
-        </p:txBody>
-      </p:sp>
-      <p:sp>
-        <p:nvSpPr>
-          <p:cNvPr id="9006" name="TextBox 9005"/>
+              <a:t>放入对应实例的调度队列；它不选节点，只决定 Pod 去哪，失败时触发回退</a:t>
+            </a:r>
+          </a:p>
+        </p:txBody>
+      </p:sp>
+      <p:sp>
+        <p:nvSpPr>
+          <p:cNvPr id="9013" name="TextBox 9012"/>
           <p:cNvSpPr txBox="1"/>
           <p:nvPr/>
         </p:nvSpPr>
@@ -30336,49 +30654,9 @@
           </a:p>
         </p:txBody>
       </p:sp>
-      <p:sp>
-        <p:nvSpPr>
-          <p:cNvPr id="9003" name="TextBox 9002"/>
-          <p:cNvSpPr txBox="1"/>
-          <p:nvPr/>
-        </p:nvSpPr>
-        <p:spPr>
-          <a:xfrm>
-            <a:off x="566928" y="1261872"/>
-            <a:ext cx="10881360" cy="438912"/>
-          </a:xfrm>
-          <a:prstGeom prst="rect">
-            <a:avLst/>
-          </a:prstGeom>
-          <a:noFill/>
-        </p:spPr>
-        <p:txBody>
-          <a:bodyPr wrap="square" anchor="ctr" lIns="0" rIns="0" tIns="0" bIns="0">
-            <a:spAutoFit/>
-          </a:bodyPr>
-          <a:lstStyle/>
-          <a:p>
-            <a:pPr algn="l">
-              <a:lnSpc>
-                <a:spcPct val="110000"/>
-              </a:lnSpc>
-            </a:pPr>
-            <a:r>
-              <a:rPr sz="1800" b="1">
-                <a:solidFill>
-                  <a:srgbClr val="0070C0"/>
-                </a:solidFill>
-                <a:latin typeface="Arial"/>
-                <a:ea typeface="微软雅黑"/>
-              </a:rPr>
-              <a:t>Filter → Score → Reserve → Permit，产出目标节点后交给 Binder 落盘</a:t>
-            </a:r>
-          </a:p>
-        </p:txBody>
-      </p:sp>
       <p:pic>
         <p:nvPicPr>
-          <p:cNvPr id="9004" name="Picture 9003" descr="fig3-4-scheduler-flow.png"/>
+          <p:cNvPr id="9003" name="Picture 9002" descr="fig3-4-scheduler-flow.png"/>
           <p:cNvPicPr>
             <a:picLocks noChangeAspect="1"/>
           </p:cNvPicPr>
@@ -30392,8 +30670,8 @@
         </p:blipFill>
         <p:spPr>
           <a:xfrm>
-            <a:off x="4999282" y="1664208"/>
-            <a:ext cx="6506354" cy="4251960"/>
+            <a:off x="3247347" y="868680"/>
+            <a:ext cx="5666825" cy="3703320"/>
           </a:xfrm>
           <a:prstGeom prst="rect">
             <a:avLst/>
@@ -30402,14 +30680,104 @@
       </p:pic>
       <p:sp>
         <p:nvSpPr>
-          <p:cNvPr id="9005" name="TextBox 9004"/>
+          <p:cNvPr id="9004" name="Rounded Rectangle 9003"/>
+          <p:cNvSpPr/>
+          <p:nvPr/>
+        </p:nvSpPr>
+        <p:spPr>
+          <a:xfrm>
+            <a:off x="566928" y="4754880"/>
+            <a:ext cx="3535680" cy="1417320"/>
+          </a:xfrm>
+          <a:prstGeom prst="roundRect">
+            <a:avLst/>
+          </a:prstGeom>
+          <a:solidFill>
+            <a:srgbClr val="FFFFFF"/>
+          </a:solidFill>
+          <a:ln w="9525">
+            <a:solidFill>
+              <a:srgbClr val="D6E3F0"/>
+            </a:solidFill>
+          </a:ln>
+          <a:effectLst/>
+        </p:spPr>
+        <p:style>
+          <a:lnRef idx="1">
+            <a:schemeClr val="accent1"/>
+          </a:lnRef>
+          <a:fillRef idx="3">
+            <a:schemeClr val="accent1"/>
+          </a:fillRef>
+          <a:effectRef idx="2">
+            <a:schemeClr val="accent1"/>
+          </a:effectRef>
+          <a:fontRef idx="minor">
+            <a:schemeClr val="lt1"/>
+          </a:fontRef>
+        </p:style>
+        <p:txBody>
+          <a:bodyPr rtlCol="0" anchor="ctr"/>
+          <a:lstStyle/>
+          <a:p>
+            <a:pPr algn="ctr"/>
+          </a:p>
+        </p:txBody>
+      </p:sp>
+      <p:sp>
+        <p:nvSpPr>
+          <p:cNvPr id="9005" name="Rectangle 9004"/>
+          <p:cNvSpPr/>
+          <p:nvPr/>
+        </p:nvSpPr>
+        <p:spPr>
+          <a:xfrm>
+            <a:off x="566928" y="4754880"/>
+            <a:ext cx="50292" cy="1417320"/>
+          </a:xfrm>
+          <a:prstGeom prst="rect">
+            <a:avLst/>
+          </a:prstGeom>
+          <a:solidFill>
+            <a:srgbClr val="113E6A"/>
+          </a:solidFill>
+          <a:ln>
+            <a:noFill/>
+          </a:ln>
+          <a:effectLst/>
+        </p:spPr>
+        <p:style>
+          <a:lnRef idx="1">
+            <a:schemeClr val="accent1"/>
+          </a:lnRef>
+          <a:fillRef idx="3">
+            <a:schemeClr val="accent1"/>
+          </a:fillRef>
+          <a:effectRef idx="2">
+            <a:schemeClr val="accent1"/>
+          </a:effectRef>
+          <a:fontRef idx="minor">
+            <a:schemeClr val="lt1"/>
+          </a:fontRef>
+        </p:style>
+        <p:txBody>
+          <a:bodyPr rtlCol="0" anchor="ctr"/>
+          <a:lstStyle/>
+          <a:p>
+            <a:pPr algn="ctr"/>
+          </a:p>
+        </p:txBody>
+      </p:sp>
+      <p:sp>
+        <p:nvSpPr>
+          <p:cNvPr id="9006" name="TextBox 9005"/>
           <p:cNvSpPr txBox="1"/>
           <p:nvPr/>
         </p:nvSpPr>
         <p:spPr>
           <a:xfrm>
-            <a:off x="566928" y="2011680"/>
-            <a:ext cx="4160520" cy="1417320"/>
+            <a:off x="749808" y="4864608"/>
+            <a:ext cx="3224784" cy="1234440"/>
           </a:xfrm>
           <a:prstGeom prst="rect">
             <a:avLst/>
@@ -30422,67 +30790,335 @@
           </a:bodyPr>
           <a:lstStyle/>
           <a:p>
+            <a:pPr algn="l"/>
+            <a:r>
+              <a:rPr sz="1500" b="1">
+                <a:solidFill>
+                  <a:srgbClr val="113E6A"/>
+                </a:solidFill>
+                <a:latin typeface="Arial"/>
+                <a:ea typeface="微软雅黑"/>
+              </a:rPr>
+              <a:t>① Filter</a:t>
+            </a:r>
+          </a:p>
+          <a:p>
             <a:pPr algn="l">
               <a:lnSpc>
-                <a:spcPct val="115000"/>
+                <a:spcPct val="118000"/>
               </a:lnSpc>
+              <a:spcBef>
+                <a:spcPts val="400"/>
+              </a:spcBef>
             </a:pPr>
             <a:r>
-              <a:rPr sz="1550" b="0">
+              <a:rPr sz="1250" b="0">
                 <a:solidFill>
                   <a:srgbClr val="2E2C2C"/>
                 </a:solidFill>
                 <a:latin typeface="Arial"/>
                 <a:ea typeface="微软雅黑"/>
               </a:rPr>
-              <a:t>▪  Filter：在分区内过滤候选节点</a:t>
+              <a:t>只在本分区内的节点上过滤，排除资源不足、约束不满足的候选</a:t>
+            </a:r>
+          </a:p>
+        </p:txBody>
+      </p:sp>
+      <p:sp>
+        <p:nvSpPr>
+          <p:cNvPr id="9007" name="Rounded Rectangle 9006"/>
+          <p:cNvSpPr/>
+          <p:nvPr/>
+        </p:nvSpPr>
+        <p:spPr>
+          <a:xfrm>
+            <a:off x="4331208" y="4754880"/>
+            <a:ext cx="3535680" cy="1417320"/>
+          </a:xfrm>
+          <a:prstGeom prst="roundRect">
+            <a:avLst/>
+          </a:prstGeom>
+          <a:solidFill>
+            <a:srgbClr val="FFFFFF"/>
+          </a:solidFill>
+          <a:ln w="9525">
+            <a:solidFill>
+              <a:srgbClr val="D6E3F0"/>
+            </a:solidFill>
+          </a:ln>
+          <a:effectLst/>
+        </p:spPr>
+        <p:style>
+          <a:lnRef idx="1">
+            <a:schemeClr val="accent1"/>
+          </a:lnRef>
+          <a:fillRef idx="3">
+            <a:schemeClr val="accent1"/>
+          </a:fillRef>
+          <a:effectRef idx="2">
+            <a:schemeClr val="accent1"/>
+          </a:effectRef>
+          <a:fontRef idx="minor">
+            <a:schemeClr val="lt1"/>
+          </a:fontRef>
+        </p:style>
+        <p:txBody>
+          <a:bodyPr rtlCol="0" anchor="ctr"/>
+          <a:lstStyle/>
+          <a:p>
+            <a:pPr algn="ctr"/>
+          </a:p>
+        </p:txBody>
+      </p:sp>
+      <p:sp>
+        <p:nvSpPr>
+          <p:cNvPr id="9008" name="Rectangle 9007"/>
+          <p:cNvSpPr/>
+          <p:nvPr/>
+        </p:nvSpPr>
+        <p:spPr>
+          <a:xfrm>
+            <a:off x="4331208" y="4754880"/>
+            <a:ext cx="50292" cy="1417320"/>
+          </a:xfrm>
+          <a:prstGeom prst="rect">
+            <a:avLst/>
+          </a:prstGeom>
+          <a:solidFill>
+            <a:srgbClr val="113E6A"/>
+          </a:solidFill>
+          <a:ln>
+            <a:noFill/>
+          </a:ln>
+          <a:effectLst/>
+        </p:spPr>
+        <p:style>
+          <a:lnRef idx="1">
+            <a:schemeClr val="accent1"/>
+          </a:lnRef>
+          <a:fillRef idx="3">
+            <a:schemeClr val="accent1"/>
+          </a:fillRef>
+          <a:effectRef idx="2">
+            <a:schemeClr val="accent1"/>
+          </a:effectRef>
+          <a:fontRef idx="minor">
+            <a:schemeClr val="lt1"/>
+          </a:fontRef>
+        </p:style>
+        <p:txBody>
+          <a:bodyPr rtlCol="0" anchor="ctr"/>
+          <a:lstStyle/>
+          <a:p>
+            <a:pPr algn="ctr"/>
+          </a:p>
+        </p:txBody>
+      </p:sp>
+      <p:sp>
+        <p:nvSpPr>
+          <p:cNvPr id="9009" name="TextBox 9008"/>
+          <p:cNvSpPr txBox="1"/>
+          <p:nvPr/>
+        </p:nvSpPr>
+        <p:spPr>
+          <a:xfrm>
+            <a:off x="4514088" y="4864608"/>
+            <a:ext cx="3224784" cy="1234440"/>
+          </a:xfrm>
+          <a:prstGeom prst="rect">
+            <a:avLst/>
+          </a:prstGeom>
+          <a:noFill/>
+        </p:spPr>
+        <p:txBody>
+          <a:bodyPr wrap="square" anchor="t" lIns="0" rIns="0" tIns="0" bIns="0">
+            <a:spAutoFit/>
+          </a:bodyPr>
+          <a:lstStyle/>
+          <a:p>
+            <a:pPr algn="l"/>
+            <a:r>
+              <a:rPr sz="1500" b="1">
+                <a:solidFill>
+                  <a:srgbClr val="113E6A"/>
+                </a:solidFill>
+                <a:latin typeface="Arial"/>
+                <a:ea typeface="微软雅黑"/>
+              </a:rPr>
+              <a:t>② Score</a:t>
             </a:r>
           </a:p>
           <a:p>
             <a:pPr algn="l">
               <a:lnSpc>
-                <a:spcPct val="115000"/>
+                <a:spcPct val="118000"/>
               </a:lnSpc>
               <a:spcBef>
-                <a:spcPts val="1400"/>
+                <a:spcPts val="400"/>
               </a:spcBef>
             </a:pPr>
             <a:r>
-              <a:rPr sz="1550" b="0">
+              <a:rPr sz="1250" b="0">
                 <a:solidFill>
                   <a:srgbClr val="2E2C2C"/>
                 </a:solidFill>
                 <a:latin typeface="Arial"/>
                 <a:ea typeface="微软雅黑"/>
               </a:rPr>
-              <a:t>▪  Score：打分选出最优节点</a:t>
+              <a:t>对候选节点打分排序，选出最优节点作为目标</a:t>
+            </a:r>
+          </a:p>
+        </p:txBody>
+      </p:sp>
+      <p:sp>
+        <p:nvSpPr>
+          <p:cNvPr id="9010" name="Rounded Rectangle 9009"/>
+          <p:cNvSpPr/>
+          <p:nvPr/>
+        </p:nvSpPr>
+        <p:spPr>
+          <a:xfrm>
+            <a:off x="8095488" y="4754880"/>
+            <a:ext cx="3535680" cy="1417320"/>
+          </a:xfrm>
+          <a:prstGeom prst="roundRect">
+            <a:avLst/>
+          </a:prstGeom>
+          <a:solidFill>
+            <a:srgbClr val="FFFFFF"/>
+          </a:solidFill>
+          <a:ln w="9525">
+            <a:solidFill>
+              <a:srgbClr val="D6E3F0"/>
+            </a:solidFill>
+          </a:ln>
+          <a:effectLst/>
+        </p:spPr>
+        <p:style>
+          <a:lnRef idx="1">
+            <a:schemeClr val="accent1"/>
+          </a:lnRef>
+          <a:fillRef idx="3">
+            <a:schemeClr val="accent1"/>
+          </a:fillRef>
+          <a:effectRef idx="2">
+            <a:schemeClr val="accent1"/>
+          </a:effectRef>
+          <a:fontRef idx="minor">
+            <a:schemeClr val="lt1"/>
+          </a:fontRef>
+        </p:style>
+        <p:txBody>
+          <a:bodyPr rtlCol="0" anchor="ctr"/>
+          <a:lstStyle/>
+          <a:p>
+            <a:pPr algn="ctr"/>
+          </a:p>
+        </p:txBody>
+      </p:sp>
+      <p:sp>
+        <p:nvSpPr>
+          <p:cNvPr id="9011" name="Rectangle 9010"/>
+          <p:cNvSpPr/>
+          <p:nvPr/>
+        </p:nvSpPr>
+        <p:spPr>
+          <a:xfrm>
+            <a:off x="8095488" y="4754880"/>
+            <a:ext cx="50292" cy="1417320"/>
+          </a:xfrm>
+          <a:prstGeom prst="rect">
+            <a:avLst/>
+          </a:prstGeom>
+          <a:solidFill>
+            <a:srgbClr val="113E6A"/>
+          </a:solidFill>
+          <a:ln>
+            <a:noFill/>
+          </a:ln>
+          <a:effectLst/>
+        </p:spPr>
+        <p:style>
+          <a:lnRef idx="1">
+            <a:schemeClr val="accent1"/>
+          </a:lnRef>
+          <a:fillRef idx="3">
+            <a:schemeClr val="accent1"/>
+          </a:fillRef>
+          <a:effectRef idx="2">
+            <a:schemeClr val="accent1"/>
+          </a:effectRef>
+          <a:fontRef idx="minor">
+            <a:schemeClr val="lt1"/>
+          </a:fontRef>
+        </p:style>
+        <p:txBody>
+          <a:bodyPr rtlCol="0" anchor="ctr"/>
+          <a:lstStyle/>
+          <a:p>
+            <a:pPr algn="ctr"/>
+          </a:p>
+        </p:txBody>
+      </p:sp>
+      <p:sp>
+        <p:nvSpPr>
+          <p:cNvPr id="9012" name="TextBox 9011"/>
+          <p:cNvSpPr txBox="1"/>
+          <p:nvPr/>
+        </p:nvSpPr>
+        <p:spPr>
+          <a:xfrm>
+            <a:off x="8278367" y="4864608"/>
+            <a:ext cx="3224784" cy="1234440"/>
+          </a:xfrm>
+          <a:prstGeom prst="rect">
+            <a:avLst/>
+          </a:prstGeom>
+          <a:noFill/>
+        </p:spPr>
+        <p:txBody>
+          <a:bodyPr wrap="square" anchor="t" lIns="0" rIns="0" tIns="0" bIns="0">
+            <a:spAutoFit/>
+          </a:bodyPr>
+          <a:lstStyle/>
+          <a:p>
+            <a:pPr algn="l"/>
+            <a:r>
+              <a:rPr sz="1500" b="1">
+                <a:solidFill>
+                  <a:srgbClr val="113E6A"/>
+                </a:solidFill>
+                <a:latin typeface="Arial"/>
+                <a:ea typeface="微软雅黑"/>
+              </a:rPr>
+              <a:t>③ Reserve / Permit</a:t>
             </a:r>
           </a:p>
           <a:p>
             <a:pPr algn="l">
               <a:lnSpc>
-                <a:spcPct val="115000"/>
+                <a:spcPct val="118000"/>
               </a:lnSpc>
               <a:spcBef>
-                <a:spcPts val="1400"/>
+                <a:spcPts val="400"/>
               </a:spcBef>
             </a:pPr>
             <a:r>
-              <a:rPr sz="1550" b="0">
+              <a:rPr sz="1250" b="0">
                 <a:solidFill>
                   <a:srgbClr val="2E2C2C"/>
                 </a:solidFill>
                 <a:latin typeface="Arial"/>
                 <a:ea typeface="微软雅黑"/>
               </a:rPr>
-              <a:t>▪  Reserve/Permit 后交 Binder</a:t>
-            </a:r>
-          </a:p>
-        </p:txBody>
-      </p:sp>
-      <p:sp>
-        <p:nvSpPr>
-          <p:cNvPr id="9006" name="TextBox 9005"/>
+              <a:t>预留资源并放行，产出目标节点后交给 Binder 落盘</a:t>
+            </a:r>
+          </a:p>
+        </p:txBody>
+      </p:sp>
+      <p:sp>
+        <p:nvSpPr>
+          <p:cNvPr id="9013" name="TextBox 9012"/>
           <p:cNvSpPr txBox="1"/>
           <p:nvPr/>
         </p:nvSpPr>

</xml_diff>

<commit_message>
fix(thesis): 修正 Dispatcher / Scheduler 流程页的步骤归属与描述
作者指出「归属校验」不是 Dispatcher 的职责——它实际由 Binder 的
NodeValidator（Layer 0）在 Bind 前执行。按论文 §3.3 / §3.4 重写：

Dispatcher（P6）：
① 排序入队：nodeName 为空且无 scheduler-name 注解的新 Pod，按 FIFO 进入有序队列
② 分发决策：PodGroup 成员复用该组已分配实例，否则按 MaxIdle 加权轮询挑最空闲实例
③ 写入并跟踪：PatchPod 写 scheduler-name；失败进不可调度队列等待重分

Scheduler（P7，原文无 Permit 环节，一并更正）：
① 入队与预处理：只接 scheduler-name 匹配自身的 Pod，pre-queue 校验 PodGroup/亲和依赖
② 调度循环：activeQ → Filter → Score → Reserve（写 Assumed 状态）
③ 绑定与回流：调 Binder 执行 Bind；失败进 backoffQ 指数退避，多次失败退回 Dispatcher

P5 的 Scheduler 卡片同步去掉 Permit。讲稿按真实流程改写（字数不变，18.8 分钟）。
</commit_message>
<xml_diff>
--- a/docs/thesis/defense/答辩PPT-北航模板版.pptx
+++ b/docs/thesis/defense/答辩PPT-北航模板版.pptx
@@ -30014,7 +30014,7 @@
                 <a:latin typeface="Arial"/>
                 <a:ea typeface="微软雅黑"/>
               </a:rPr>
-              <a:t>① 归属校验</a:t>
+              <a:t>① 排序入队</a:t>
             </a:r>
           </a:p>
           <a:p>
@@ -30034,7 +30034,7 @@
                 <a:latin typeface="Arial"/>
                 <a:ea typeface="微软雅黑"/>
               </a:rPr>
-              <a:t>Bind 前校验目标节点的 eno.io/scheduler-name 注解，把分区归属漂移的 Pod 拦在门外</a:t>
+              <a:t>Informer 观察到 nodeName 为空、且无 scheduler-name 注解的新 Pod，按 FIFO 排序后进入有序队列</a:t>
             </a:r>
           </a:p>
         </p:txBody>
@@ -30160,7 +30160,7 @@
                 <a:latin typeface="Arial"/>
                 <a:ea typeface="微软雅黑"/>
               </a:rPr>
-              <a:t>② 分区选择</a:t>
+              <a:t>② 分发决策</a:t>
             </a:r>
           </a:p>
           <a:p>
@@ -30180,7 +30180,7 @@
                 <a:latin typeface="Arial"/>
                 <a:ea typeface="微软雅黑"/>
               </a:rPr>
-              <a:t>依据节点分区表与实例负载，决定这个 Pod 交给哪个 Scheduler 实例处理</a:t>
+              <a:t>PodGroup 成员复用该组已分配的实例；否则按负载均衡（MaxIdle 加权轮询）挑选最空闲的 Scheduler</a:t>
             </a:r>
           </a:p>
         </p:txBody>
@@ -30306,7 +30306,7 @@
                 <a:latin typeface="Arial"/>
                 <a:ea typeface="微软雅黑"/>
               </a:rPr>
-              <a:t>③ 入队</a:t>
+              <a:t>③ 写入并跟踪</a:t>
             </a:r>
           </a:p>
           <a:p>
@@ -30326,7 +30326,7 @@
                 <a:latin typeface="Arial"/>
                 <a:ea typeface="微软雅黑"/>
               </a:rPr>
-              <a:t>放入对应实例的调度队列；它不选节点，只决定 Pod 去哪，失败时触发回退</a:t>
+              <a:t>PatchPod 写入 scheduler-name 完成分发；持续观察绑定结果，失败进入不可调度队列等待重分</a:t>
             </a:r>
           </a:p>
         </p:txBody>
@@ -30799,7 +30799,7 @@
                 <a:latin typeface="Arial"/>
                 <a:ea typeface="微软雅黑"/>
               </a:rPr>
-              <a:t>① Filter</a:t>
+              <a:t>① 入队与预处理</a:t>
             </a:r>
           </a:p>
           <a:p>
@@ -30819,7 +30819,7 @@
                 <a:latin typeface="Arial"/>
                 <a:ea typeface="微软雅黑"/>
               </a:rPr>
-              <a:t>只在本分区内的节点上过滤，排除资源不足、约束不满足的候选</a:t>
+              <a:t>只接 scheduler-name 匹配自身的 Pod；pre-queue 插件校验 PodGroup 成员与亲和依赖，不通过则退回 Dispatcher</a:t>
             </a:r>
           </a:p>
         </p:txBody>
@@ -30945,7 +30945,7 @@
                 <a:latin typeface="Arial"/>
                 <a:ea typeface="微软雅黑"/>
               </a:rPr>
-              <a:t>② Score</a:t>
+              <a:t>② 调度循环</a:t>
             </a:r>
           </a:p>
           <a:p>
@@ -30965,7 +30965,7 @@
                 <a:latin typeface="Arial"/>
                 <a:ea typeface="微软雅黑"/>
               </a:rPr>
-              <a:t>对候选节点打分排序，选出最优节点作为目标</a:t>
+              <a:t>从 activeQ 弹出后依次 Filter（剔除硬约束不满足）、Score（打分）、Reserve（标记候选并写 Assumed 状态）</a:t>
             </a:r>
           </a:p>
         </p:txBody>
@@ -31091,7 +31091,7 @@
                 <a:latin typeface="Arial"/>
                 <a:ea typeface="微软雅黑"/>
               </a:rPr>
-              <a:t>③ Reserve / Permit</a:t>
+              <a:t>③ 绑定与回流</a:t>
             </a:r>
           </a:p>
           <a:p>
@@ -31111,7 +31111,7 @@
                 <a:latin typeface="Arial"/>
                 <a:ea typeface="微软雅黑"/>
               </a:rPr>
-              <a:t>预留资源并放行，产出目标节点后交给 Binder 落盘</a:t>
+              <a:t>Reserve 后调用 Binder 执行 Bind；失败进入 backoffQ 指数退避，多次失败则退回 Dispatcher 触发跨实例回退</a:t>
             </a:r>
           </a:p>
         </p:txBody>

</xml_diff>

<commit_message>
feat(thesis): 第 9 页 CacheAdapter 改为与架构图一致的版式
- 去掉核心句与左侧要点栏，fig5-2 居中放大（4.93×4.05 in，居中于版心）
- 图下方三列说明：① 共享同一实例 ② 零拷贝、零同步 ③ 同一份真相
- 讲稿按三块重写，与 P5/P6/P7 的"居中大图 + 图下说明"结构统一

校验：32 页、无越界、三块说明未超出卡片。
</commit_message>
<xml_diff>
--- a/docs/thesis/defense/答辩PPT-北航模板版.pptx
+++ b/docs/thesis/defense/答辩PPT-北航模板版.pptx
@@ -31903,49 +31903,9 @@
           </a:p>
         </p:txBody>
       </p:sp>
-      <p:sp>
-        <p:nvSpPr>
-          <p:cNvPr id="9003" name="TextBox 9002"/>
-          <p:cNvSpPr txBox="1"/>
-          <p:nvPr/>
-        </p:nvSpPr>
-        <p:spPr>
-          <a:xfrm>
-            <a:off x="566928" y="1261872"/>
-            <a:ext cx="10881360" cy="438912"/>
-          </a:xfrm>
-          <a:prstGeom prst="rect">
-            <a:avLst/>
-          </a:prstGeom>
-          <a:noFill/>
-        </p:spPr>
-        <p:txBody>
-          <a:bodyPr wrap="square" anchor="ctr" lIns="0" rIns="0" tIns="0" bIns="0">
-            <a:spAutoFit/>
-          </a:bodyPr>
-          <a:lstStyle/>
-          <a:p>
-            <a:pPr algn="l">
-              <a:lnSpc>
-                <a:spcPct val="110000"/>
-              </a:lnSpc>
-            </a:pPr>
-            <a:r>
-              <a:rPr sz="1800" b="1">
-                <a:solidFill>
-                  <a:srgbClr val="0070C0"/>
-                </a:solidFill>
-                <a:latin typeface="Arial"/>
-                <a:ea typeface="微软雅黑"/>
-              </a:rPr>
-              <a:t>状态以对象引用共享，不再复制，也没有跨进程同步延迟</a:t>
-            </a:r>
-          </a:p>
-        </p:txBody>
-      </p:sp>
       <p:pic>
         <p:nvPicPr>
-          <p:cNvPr id="9004" name="Picture 9003" descr="fig5-2-cache-zero-copy.png"/>
+          <p:cNvPr id="9003" name="Picture 9002" descr="fig5-2-cache-zero-copy.png"/>
           <p:cNvPicPr>
             <a:picLocks noChangeAspect="1"/>
           </p:cNvPicPr>
@@ -31959,8 +31919,8 @@
         </p:blipFill>
         <p:spPr>
           <a:xfrm>
-            <a:off x="6174622" y="1783080"/>
-            <a:ext cx="5115794" cy="4206240"/>
+            <a:off x="3828698" y="868680"/>
+            <a:ext cx="4504123" cy="3703320"/>
           </a:xfrm>
           <a:prstGeom prst="rect">
             <a:avLst/>
@@ -31969,14 +31929,104 @@
       </p:pic>
       <p:sp>
         <p:nvSpPr>
-          <p:cNvPr id="9005" name="TextBox 9004"/>
+          <p:cNvPr id="9004" name="Rounded Rectangle 9003"/>
+          <p:cNvSpPr/>
+          <p:nvPr/>
+        </p:nvSpPr>
+        <p:spPr>
+          <a:xfrm>
+            <a:off x="566928" y="4754880"/>
+            <a:ext cx="3535680" cy="1417320"/>
+          </a:xfrm>
+          <a:prstGeom prst="roundRect">
+            <a:avLst/>
+          </a:prstGeom>
+          <a:solidFill>
+            <a:srgbClr val="FFFFFF"/>
+          </a:solidFill>
+          <a:ln w="9525">
+            <a:solidFill>
+              <a:srgbClr val="D6E3F0"/>
+            </a:solidFill>
+          </a:ln>
+          <a:effectLst/>
+        </p:spPr>
+        <p:style>
+          <a:lnRef idx="1">
+            <a:schemeClr val="accent1"/>
+          </a:lnRef>
+          <a:fillRef idx="3">
+            <a:schemeClr val="accent1"/>
+          </a:fillRef>
+          <a:effectRef idx="2">
+            <a:schemeClr val="accent1"/>
+          </a:effectRef>
+          <a:fontRef idx="minor">
+            <a:schemeClr val="lt1"/>
+          </a:fontRef>
+        </p:style>
+        <p:txBody>
+          <a:bodyPr rtlCol="0" anchor="ctr"/>
+          <a:lstStyle/>
+          <a:p>
+            <a:pPr algn="ctr"/>
+          </a:p>
+        </p:txBody>
+      </p:sp>
+      <p:sp>
+        <p:nvSpPr>
+          <p:cNvPr id="9005" name="Rectangle 9004"/>
+          <p:cNvSpPr/>
+          <p:nvPr/>
+        </p:nvSpPr>
+        <p:spPr>
+          <a:xfrm>
+            <a:off x="566928" y="4754880"/>
+            <a:ext cx="50292" cy="1417320"/>
+          </a:xfrm>
+          <a:prstGeom prst="rect">
+            <a:avLst/>
+          </a:prstGeom>
+          <a:solidFill>
+            <a:srgbClr val="113E6A"/>
+          </a:solidFill>
+          <a:ln>
+            <a:noFill/>
+          </a:ln>
+          <a:effectLst/>
+        </p:spPr>
+        <p:style>
+          <a:lnRef idx="1">
+            <a:schemeClr val="accent1"/>
+          </a:lnRef>
+          <a:fillRef idx="3">
+            <a:schemeClr val="accent1"/>
+          </a:fillRef>
+          <a:effectRef idx="2">
+            <a:schemeClr val="accent1"/>
+          </a:effectRef>
+          <a:fontRef idx="minor">
+            <a:schemeClr val="lt1"/>
+          </a:fontRef>
+        </p:style>
+        <p:txBody>
+          <a:bodyPr rtlCol="0" anchor="ctr"/>
+          <a:lstStyle/>
+          <a:p>
+            <a:pPr algn="ctr"/>
+          </a:p>
+        </p:txBody>
+      </p:sp>
+      <p:sp>
+        <p:nvSpPr>
+          <p:cNvPr id="9006" name="TextBox 9005"/>
           <p:cNvSpPr txBox="1"/>
           <p:nvPr/>
         </p:nvSpPr>
         <p:spPr>
           <a:xfrm>
-            <a:off x="566928" y="2011680"/>
-            <a:ext cx="5029200" cy="1417320"/>
+            <a:off x="749808" y="4864608"/>
+            <a:ext cx="3224784" cy="1234440"/>
           </a:xfrm>
           <a:prstGeom prst="rect">
             <a:avLst/>
@@ -31989,67 +32039,335 @@
           </a:bodyPr>
           <a:lstStyle/>
           <a:p>
+            <a:pPr algn="l"/>
+            <a:r>
+              <a:rPr sz="1500" b="1">
+                <a:solidFill>
+                  <a:srgbClr val="113E6A"/>
+                </a:solidFill>
+                <a:latin typeface="Arial"/>
+                <a:ea typeface="微软雅黑"/>
+              </a:rPr>
+              <a:t>① 共享同一实例</a:t>
+            </a:r>
+          </a:p>
+          <a:p>
             <a:pPr algn="l">
               <a:lnSpc>
-                <a:spcPct val="115000"/>
+                <a:spcPct val="118000"/>
               </a:lnSpc>
+              <a:spcBef>
+                <a:spcPts val="400"/>
+              </a:spcBef>
             </a:pPr>
             <a:r>
-              <a:rPr sz="1550" b="0">
+              <a:rPr sz="1250" b="0">
                 <a:solidFill>
                   <a:srgbClr val="2E2C2C"/>
                 </a:solidFill>
                 <a:latin typeface="Arial"/>
                 <a:ea typeface="微软雅黑"/>
               </a:rPr>
-              <a:t>▪  对象引用而非序列化拷贝</a:t>
+              <a:t>CacheAdapter 把 Scheduler 的 SchedulerCache 交给进程内 Binder，两边持有同一份缓存对象</a:t>
+            </a:r>
+          </a:p>
+        </p:txBody>
+      </p:sp>
+      <p:sp>
+        <p:nvSpPr>
+          <p:cNvPr id="9007" name="Rounded Rectangle 9006"/>
+          <p:cNvSpPr/>
+          <p:nvPr/>
+        </p:nvSpPr>
+        <p:spPr>
+          <a:xfrm>
+            <a:off x="4331208" y="4754880"/>
+            <a:ext cx="3535680" cy="1417320"/>
+          </a:xfrm>
+          <a:prstGeom prst="roundRect">
+            <a:avLst/>
+          </a:prstGeom>
+          <a:solidFill>
+            <a:srgbClr val="FFFFFF"/>
+          </a:solidFill>
+          <a:ln w="9525">
+            <a:solidFill>
+              <a:srgbClr val="D6E3F0"/>
+            </a:solidFill>
+          </a:ln>
+          <a:effectLst/>
+        </p:spPr>
+        <p:style>
+          <a:lnRef idx="1">
+            <a:schemeClr val="accent1"/>
+          </a:lnRef>
+          <a:fillRef idx="3">
+            <a:schemeClr val="accent1"/>
+          </a:fillRef>
+          <a:effectRef idx="2">
+            <a:schemeClr val="accent1"/>
+          </a:effectRef>
+          <a:fontRef idx="minor">
+            <a:schemeClr val="lt1"/>
+          </a:fontRef>
+        </p:style>
+        <p:txBody>
+          <a:bodyPr rtlCol="0" anchor="ctr"/>
+          <a:lstStyle/>
+          <a:p>
+            <a:pPr algn="ctr"/>
+          </a:p>
+        </p:txBody>
+      </p:sp>
+      <p:sp>
+        <p:nvSpPr>
+          <p:cNvPr id="9008" name="Rectangle 9007"/>
+          <p:cNvSpPr/>
+          <p:nvPr/>
+        </p:nvSpPr>
+        <p:spPr>
+          <a:xfrm>
+            <a:off x="4331208" y="4754880"/>
+            <a:ext cx="50292" cy="1417320"/>
+          </a:xfrm>
+          <a:prstGeom prst="rect">
+            <a:avLst/>
+          </a:prstGeom>
+          <a:solidFill>
+            <a:srgbClr val="113E6A"/>
+          </a:solidFill>
+          <a:ln>
+            <a:noFill/>
+          </a:ln>
+          <a:effectLst/>
+        </p:spPr>
+        <p:style>
+          <a:lnRef idx="1">
+            <a:schemeClr val="accent1"/>
+          </a:lnRef>
+          <a:fillRef idx="3">
+            <a:schemeClr val="accent1"/>
+          </a:fillRef>
+          <a:effectRef idx="2">
+            <a:schemeClr val="accent1"/>
+          </a:effectRef>
+          <a:fontRef idx="minor">
+            <a:schemeClr val="lt1"/>
+          </a:fontRef>
+        </p:style>
+        <p:txBody>
+          <a:bodyPr rtlCol="0" anchor="ctr"/>
+          <a:lstStyle/>
+          <a:p>
+            <a:pPr algn="ctr"/>
+          </a:p>
+        </p:txBody>
+      </p:sp>
+      <p:sp>
+        <p:nvSpPr>
+          <p:cNvPr id="9009" name="TextBox 9008"/>
+          <p:cNvSpPr txBox="1"/>
+          <p:nvPr/>
+        </p:nvSpPr>
+        <p:spPr>
+          <a:xfrm>
+            <a:off x="4514088" y="4864608"/>
+            <a:ext cx="3224784" cy="1234440"/>
+          </a:xfrm>
+          <a:prstGeom prst="rect">
+            <a:avLst/>
+          </a:prstGeom>
+          <a:noFill/>
+        </p:spPr>
+        <p:txBody>
+          <a:bodyPr wrap="square" anchor="t" lIns="0" rIns="0" tIns="0" bIns="0">
+            <a:spAutoFit/>
+          </a:bodyPr>
+          <a:lstStyle/>
+          <a:p>
+            <a:pPr algn="l"/>
+            <a:r>
+              <a:rPr sz="1500" b="1">
+                <a:solidFill>
+                  <a:srgbClr val="113E6A"/>
+                </a:solidFill>
+                <a:latin typeface="Arial"/>
+                <a:ea typeface="微软雅黑"/>
+              </a:rPr>
+              <a:t>② 零拷贝、零同步</a:t>
             </a:r>
           </a:p>
           <a:p>
             <a:pPr algn="l">
               <a:lnSpc>
-                <a:spcPct val="115000"/>
+                <a:spcPct val="118000"/>
               </a:lnSpc>
               <a:spcBef>
-                <a:spcPts val="1400"/>
+                <a:spcPts val="400"/>
               </a:spcBef>
             </a:pPr>
             <a:r>
-              <a:rPr sz="1550" b="0">
+              <a:rPr sz="1250" b="0">
                 <a:solidFill>
                   <a:srgbClr val="2E2C2C"/>
                 </a:solidFill>
                 <a:latin typeface="Arial"/>
                 <a:ea typeface="微软雅黑"/>
               </a:rPr>
-              <a:t>▪  进程内 Binder 与 Scheduler 同视图</a:t>
+              <a:t>状态以引用传递，不做序列化复制，也没有跨进程的同步延迟与网络往返</a:t>
+            </a:r>
+          </a:p>
+        </p:txBody>
+      </p:sp>
+      <p:sp>
+        <p:nvSpPr>
+          <p:cNvPr id="9010" name="Rounded Rectangle 9009"/>
+          <p:cNvSpPr/>
+          <p:nvPr/>
+        </p:nvSpPr>
+        <p:spPr>
+          <a:xfrm>
+            <a:off x="8095488" y="4754880"/>
+            <a:ext cx="3535680" cy="1417320"/>
+          </a:xfrm>
+          <a:prstGeom prst="roundRect">
+            <a:avLst/>
+          </a:prstGeom>
+          <a:solidFill>
+            <a:srgbClr val="FFFFFF"/>
+          </a:solidFill>
+          <a:ln w="9525">
+            <a:solidFill>
+              <a:srgbClr val="D6E3F0"/>
+            </a:solidFill>
+          </a:ln>
+          <a:effectLst/>
+        </p:spPr>
+        <p:style>
+          <a:lnRef idx="1">
+            <a:schemeClr val="accent1"/>
+          </a:lnRef>
+          <a:fillRef idx="3">
+            <a:schemeClr val="accent1"/>
+          </a:fillRef>
+          <a:effectRef idx="2">
+            <a:schemeClr val="accent1"/>
+          </a:effectRef>
+          <a:fontRef idx="minor">
+            <a:schemeClr val="lt1"/>
+          </a:fontRef>
+        </p:style>
+        <p:txBody>
+          <a:bodyPr rtlCol="0" anchor="ctr"/>
+          <a:lstStyle/>
+          <a:p>
+            <a:pPr algn="ctr"/>
+          </a:p>
+        </p:txBody>
+      </p:sp>
+      <p:sp>
+        <p:nvSpPr>
+          <p:cNvPr id="9011" name="Rectangle 9010"/>
+          <p:cNvSpPr/>
+          <p:nvPr/>
+        </p:nvSpPr>
+        <p:spPr>
+          <a:xfrm>
+            <a:off x="8095488" y="4754880"/>
+            <a:ext cx="50292" cy="1417320"/>
+          </a:xfrm>
+          <a:prstGeom prst="rect">
+            <a:avLst/>
+          </a:prstGeom>
+          <a:solidFill>
+            <a:srgbClr val="113E6A"/>
+          </a:solidFill>
+          <a:ln>
+            <a:noFill/>
+          </a:ln>
+          <a:effectLst/>
+        </p:spPr>
+        <p:style>
+          <a:lnRef idx="1">
+            <a:schemeClr val="accent1"/>
+          </a:lnRef>
+          <a:fillRef idx="3">
+            <a:schemeClr val="accent1"/>
+          </a:fillRef>
+          <a:effectRef idx="2">
+            <a:schemeClr val="accent1"/>
+          </a:effectRef>
+          <a:fontRef idx="minor">
+            <a:schemeClr val="lt1"/>
+          </a:fontRef>
+        </p:style>
+        <p:txBody>
+          <a:bodyPr rtlCol="0" anchor="ctr"/>
+          <a:lstStyle/>
+          <a:p>
+            <a:pPr algn="ctr"/>
+          </a:p>
+        </p:txBody>
+      </p:sp>
+      <p:sp>
+        <p:nvSpPr>
+          <p:cNvPr id="9012" name="TextBox 9011"/>
+          <p:cNvSpPr txBox="1"/>
+          <p:nvPr/>
+        </p:nvSpPr>
+        <p:spPr>
+          <a:xfrm>
+            <a:off x="8278367" y="4864608"/>
+            <a:ext cx="3224784" cy="1234440"/>
+          </a:xfrm>
+          <a:prstGeom prst="rect">
+            <a:avLst/>
+          </a:prstGeom>
+          <a:noFill/>
+        </p:spPr>
+        <p:txBody>
+          <a:bodyPr wrap="square" anchor="t" lIns="0" rIns="0" tIns="0" bIns="0">
+            <a:spAutoFit/>
+          </a:bodyPr>
+          <a:lstStyle/>
+          <a:p>
+            <a:pPr algn="l"/>
+            <a:r>
+              <a:rPr sz="1500" b="1">
+                <a:solidFill>
+                  <a:srgbClr val="113E6A"/>
+                </a:solidFill>
+                <a:latin typeface="Arial"/>
+                <a:ea typeface="微软雅黑"/>
+              </a:rPr>
+              <a:t>③ 同一份真相</a:t>
             </a:r>
           </a:p>
           <a:p>
             <a:pPr algn="l">
               <a:lnSpc>
-                <a:spcPct val="115000"/>
+                <a:spcPct val="118000"/>
               </a:lnSpc>
               <a:spcBef>
-                <a:spcPts val="1400"/>
+                <a:spcPts val="400"/>
               </a:spcBef>
             </a:pPr>
             <a:r>
-              <a:rPr sz="1550" b="0">
+              <a:rPr sz="1250" b="0">
                 <a:solidFill>
                   <a:srgbClr val="2E2C2C"/>
                 </a:solidFill>
                 <a:latin typeface="Arial"/>
                 <a:ea typeface="微软雅黑"/>
               </a:rPr>
-              <a:t>▪  为一致性校验提供同一份真相</a:t>
-            </a:r>
-          </a:p>
-        </p:txBody>
-      </p:sp>
-      <p:sp>
-        <p:nvSpPr>
-          <p:cNvPr id="9006" name="TextBox 9005"/>
+              <a:t>Layer 0 的节点归属校验读的就是这份缓存，Scheduler 与 Binder 看到的状态一致</a:t>
+            </a:r>
+          </a:p>
+        </p:txBody>
+      </p:sp>
+      <p:sp>
+        <p:nvSpPr>
+          <p:cNvPr id="9013" name="TextBox 9012"/>
           <p:cNvSpPr txBox="1"/>
           <p:nvPr/>
         </p:nvSpPr>

</xml_diff>

<commit_message>
style(thesis): 第 19 页首行改为「+21.7% / +5.6%」「P99 −15.2% / −33.4%」，四行格式统一
</commit_message>
<xml_diff>
--- a/docs/thesis/defense/答辩PPT-北航模板版.pptx
+++ b/docs/thesis/defense/答辩PPT-北航模板版.pptx
@@ -15958,7 +15958,7 @@
                           <a:latin typeface="Arial"/>
                           <a:ea typeface="微软雅黑"/>
                         </a:rPr>
-                        <a:t>w3 稳态（s3 → s4）</a:t>
+                        <a:t>w3 稳态（s3 / s4）</a:t>
                       </a:r>
                     </a:p>
                   </a:txBody>
@@ -15982,7 +15982,7 @@
                           <a:latin typeface="Arial"/>
                           <a:ea typeface="微软雅黑"/>
                         </a:rPr>
-                        <a:t>+5.6%（296.7 vs 280.9）</a:t>
+                        <a:t>+21.7% / +5.6%</a:t>
                       </a:r>
                     </a:p>
                   </a:txBody>
@@ -16006,7 +16006,7 @@
                           <a:latin typeface="Arial"/>
                           <a:ea typeface="微软雅黑"/>
                         </a:rPr>
-                        <a:t>P99 0.19 vs 0.28 s（低 33.4%）</a:t>
+                        <a:t>P99 −15.2% / −33.4%</a:t>
                       </a:r>
                     </a:p>
                   </a:txBody>

</xml_diff>